<commit_message>
22-04: implementamos inserção na árvore binária de busca
</commit_message>
<xml_diff>
--- a/t1-sub1-lab/semana10 - arvore binaria de busca - conceito, insercao e percorrer/arvores binarias de busca.pptx
+++ b/t1-sub1-lab/semana10 - arvore binaria de busca - conceito, insercao e percorrer/arvores binarias de busca.pptx
@@ -4034,15 +4034,7 @@
             </a:r>
             <a:r>
               <a:rPr lang="pt-BR" dirty="0"/>
-              <a:t>que </a:t>
-            </a:r>
-            <a:r>
-              <a:rPr lang="pt-BR" dirty="0" err="1"/>
-              <a:t>oo</a:t>
-            </a:r>
-            <a:r>
-              <a:rPr lang="pt-BR" dirty="0"/>
-              <a:t> conteúdo de </a:t>
+              <a:t>que o conteúdo de </a:t>
             </a:r>
             <a:r>
               <a:rPr lang="pt-BR" i="1" dirty="0"/>

</xml_diff>